<commit_message>
Fix two figures in the Argentina dossier
The fact-check pass that had been cut short found both:

- The water-usage callout claimed a 10% cut in irrigation frees more than all
  industrial use, while the chart beside it reads 74/15/11 — 7.4 is less than
  11. Reworded to two thirds, matching Chile, which has the same ratio.
- The Cuyo panel covers Mendoza and San Juan but carried Mendoza's vineyard area
  alone (~145,000 ha). Raised to ~190,000 ha for both provinces.

South Africa needed no correction.

Co-Authored-By: Claude Opus 5 <noreply@anthropic.com>
</commit_message>
<xml_diff>
--- a/public/documents/countries/argentine.pptx
+++ b/public/documents/countries/argentine.pptx
@@ -117,7 +117,7 @@
 </p:presentation>
 </file>
 
-<file path=ppt/charts/chart10.xml><?xml version="1.0" encoding="utf-8"?>
+<file path=ppt/charts/chart1.xml><?xml version="1.0" encoding="utf-8"?>
 <c:chartSpace xmlns:c="http://schemas.openxmlformats.org/drawingml/2006/chart" xmlns:a="http://schemas.openxmlformats.org/drawingml/2006/main" xmlns:r="http://schemas.openxmlformats.org/officeDocument/2006/relationships">
   <c:date1904 val="0"/>
   <c:roundedCorners val="1"/>
@@ -362,7 +362,7 @@
 </c:chartSpace>
 </file>
 
-<file path=ppt/charts/chart11.xml><?xml version="1.0" encoding="utf-8"?>
+<file path=ppt/charts/chart2.xml><?xml version="1.0" encoding="utf-8"?>
 <c:chartSpace xmlns:c="http://schemas.openxmlformats.org/drawingml/2006/chart" xmlns:a="http://schemas.openxmlformats.org/drawingml/2006/main" xmlns:r="http://schemas.openxmlformats.org/officeDocument/2006/relationships">
   <c:date1904 val="0"/>
   <c:roundedCorners val="1"/>
@@ -670,7 +670,7 @@
 </c:chartSpace>
 </file>
 
-<file path=ppt/charts/chart12.xml><?xml version="1.0" encoding="utf-8"?>
+<file path=ppt/charts/chart3.xml><?xml version="1.0" encoding="utf-8"?>
 <c:chartSpace xmlns:c="http://schemas.openxmlformats.org/drawingml/2006/chart" xmlns:a="http://schemas.openxmlformats.org/drawingml/2006/main" xmlns:r="http://schemas.openxmlformats.org/officeDocument/2006/relationships">
   <c:date1904 val="0"/>
   <c:roundedCorners val="1"/>
@@ -5023,7 +5023,7 @@
                 <a:ea typeface="Calibri" pitchFamily="34" charset="-122"/>
                 <a:cs typeface="Calibri" pitchFamily="34" charset="-120"/>
               </a:rPr>
-              <a:t>Reducir un 10 % el consumo agrícola libera más volumen que suprimir la totalidad del uso industrial.</a:t>
+              <a:t>Reducir un 10 % el consumo agrícola libera un volumen equivalente a cerca de dos tercios de todo el uso industrial del país.</a:t>
             </a:r>
             <a:endParaRPr lang="en-US" sz="1200" dirty="0"/>
           </a:p>
@@ -6638,7 +6638,7 @@
                 <a:ea typeface="Calibri" pitchFamily="34" charset="-122"/>
                 <a:cs typeface="Calibri" pitchFamily="34" charset="-120"/>
               </a:rPr>
-              <a:t>≈ 145 000 ha de viñedo</a:t>
+              <a:t>≈ 190 000 ha de viñedo</a:t>
             </a:r>
             <a:endParaRPr lang="en-US" sz="1250" dirty="0"/>
           </a:p>

</xml_diff>